<commit_message>
Deck Mathys : couverture avec age/motif + 5 diapos documentation (exo, intra, occlusales, CBCT, profil)
- Couverture : age + motif de consultation (champs a completer), fiche cas
- Section documentation deployee en 5 diapos avec gabarits photo dedies
- Notes conferencier remappees sur 15 slides

Co-Authored-By: Claude Opus 4.8 <noreply@anthropic.com>
Claude-Session: https://claude.ai/code/session_014brP78CXMSfVZFDbExkY7E
</commit_message>
<xml_diff>
--- a/sortie/Cas_Mathys_TSS.pptx
+++ b/sortie/Cas_Mathys_TSS.pptx
@@ -16,9 +16,13 @@
     <p:sldId id="264" r:id="rId10"/>
     <p:sldId id="265" r:id="rId11"/>
     <p:sldId id="266" r:id="rId12"/>
+    <p:sldId id="267" r:id="rId13"/>
+    <p:sldId id="268" r:id="rId14"/>
+    <p:sldId id="269" r:id="rId15"/>
+    <p:sldId id="270" r:id="rId16"/>
   </p:sldIdLst>
   <p:notesMasterIdLst>
-    <p:notesMasterId r:id="rId13"/>
+    <p:notesMasterId r:id="rId17"/>
   </p:notesMasterIdLst>
   <p:sldSz cx="12191695" cy="6858000"/>
   <p:notesSz cx="6858000" cy="12191695"/>
@@ -513,7 +517,7 @@
             <a:r>
               <a:rPr lang="en-US" dirty="0"/>
               <a:t>[CARTON — ÉNERGIE : rassurer, socle solide + première étincelle.]
-Premier patient. Un enfant en denture mixte. Le cas le plus simple en apparence — et pourtant il pose déjà toute la logique des 90 minutes. Dispositif : MARPE avec deux vis de distalisation (expansion + recul des quadrants I et II). 1</a:t>
+Premier patient. Un enfant en denture mixte. Le cas le plus simple en apparence — et pourtant il pose déjà toute la logique des 90 minutes. Dispositif : MARPE avec deux vis de distalisation (expansion + recul des quadrants I et II).</a:t>
             </a:r>
             <a:endParaRPr lang="en-US" dirty="0"/>
           </a:p>
@@ -601,8 +605,8 @@
           <a:p>
             <a:r>
               <a:rPr lang="en-US" dirty="0"/>
-              <a:t>[Point 8 — LA distinction qu'Hermann trouvait floue. La marquer nettement, lentement, avec une pause entre les deux colonnes. Côté patient = émotion (sa vie) ; côté ortho = clinique (ta pratique).]
-« Pour lui, dans sa vie : traité au bon moment, une phase en moins, il aborde son adolescence avec une bouche fonctionnelle, il respire et dort mieux. [temps] Pour nous : un ancrage fiable même quand la denture ne suit pas, un geste simple, reproductible — et on repense la fenêtre d'intervention de toute une génération. » 10</a:t>
+              <a:t>[Point 6 — résultats. Laisser les images prouver, parler peu.]
+Avant/après : occlusales (gain transverse + recul des quadrants), profil, sourire. Évolution dans le temps.</a:t>
             </a:r>
             <a:endParaRPr lang="en-US" dirty="0"/>
           </a:p>
@@ -690,8 +694,10 @@
           <a:p>
             <a:r>
               <a:rPr lang="en-US" dirty="0"/>
-              <a:t>[LA CHUTE — marquer une coupure de voix avant (« Et si je devais résumer tout ça en une phrase… »), plus posée, plus large. Lance le cas suivant.]
-« Chez l'adulte, la vis vainc l'os. Chez l'enfant, elle ne vainc rien : elle ANCRE. Même outil, deux missions. Et c'est toute l'histoire des quatre-vingt-dix minutes qui viennent. » 11</a:t>
+              <a:t>[La vidéo de pose — codes du démonstrateur (le vendeur de presse-jus) : TEMPO du geste, dédramatiser, PAS de vente. Muette, je commente en direct. Clip propre, court.]
+NARRATION (par-dessus la vidéo) :
+« On commence par endormir la surface. Puis quelques gouttes sur chaque site — quelques gouttes suffisent, on endort le périoste, pas l'os. On pose la vis. Le seul piège : on n'oriente pas perpendiculairement au plan sagittal — mais perpendiculairement à l'os qu'on aborde. La vis sur le tournevis, torque sur 35. Et là… pas de forcing — on ne pousse pas comme un malade, on visse. On avance… et on s'arrête net quand la tête touche la gencive. Un scan, têtes de vis nues, direction le labo. »
+[Puis, si dispo : témoignage patient « je n'ai rien senti ».]</a:t>
             </a:r>
             <a:endParaRPr lang="en-US" dirty="0"/>
           </a:p>
@@ -715,6 +721,363 @@
             <a:fld id="{F7021451-1387-4CA6-816F-3879F97B5CBC}" type="slidenum">
               <a:rPr lang="en-US"/>
               <a:t>11</a:t>
+            </a:fld>
+            <a:endParaRPr lang="en-US"/>
+          </a:p>
+        </p:txBody>
+      </p:sp>
+    </p:spTree>
+    <p:extLst>
+      <p:ext uri="{BB962C8B-B14F-4D97-AF65-F5344CB8AC3E}">
+        <p14:creationId xmlns:p14="http://schemas.microsoft.com/office/powerpoint/2010/main" val="1024086991"/>
+      </p:ext>
+    </p:extLst>
+  </p:cSld>
+  <p:clrMapOvr>
+    <a:masterClrMapping/>
+  </p:clrMapOvr>
+</p:notes>
+</file>
+
+<file path=ppt/notesSlides/notesSlide12.xml><?xml version="1.0" encoding="utf-8"?>
+<p:notes xmlns:a="http://schemas.openxmlformats.org/drawingml/2006/main" xmlns:r="http://schemas.openxmlformats.org/officeDocument/2006/relationships" xmlns:p="http://schemas.openxmlformats.org/presentationml/2006/main">
+  <p:cSld>
+    <p:spTree>
+      <p:nvGrpSpPr>
+        <p:cNvPr id="1" name=""/>
+        <p:cNvGrpSpPr/>
+        <p:nvPr/>
+      </p:nvGrpSpPr>
+      <p:grpSpPr>
+        <a:xfrm>
+          <a:off x="0" y="0"/>
+          <a:ext cx="0" cy="0"/>
+          <a:chOff x="0" y="0"/>
+          <a:chExt cx="0" cy="0"/>
+        </a:xfrm>
+      </p:grpSpPr>
+      <p:sp>
+        <p:nvSpPr>
+          <p:cNvPr id="2" name="Slide Image Placeholder 1"/>
+          <p:cNvSpPr>
+            <a:spLocks noGrp="1" noRot="1" noChangeAspect="1"/>
+          </p:cNvSpPr>
+          <p:nvPr>
+            <p:ph type="sldImg"/>
+          </p:nvPr>
+        </p:nvSpPr>
+        <p:spPr/>
+      </p:sp>
+      <p:sp>
+        <p:nvSpPr>
+          <p:cNvPr id="3" name="Notes Placeholder 2"/>
+          <p:cNvSpPr>
+            <a:spLocks noGrp="1"/>
+          </p:cNvSpPr>
+          <p:nvPr>
+            <p:ph type="body" idx="1"/>
+          </p:nvPr>
+        </p:nvSpPr>
+        <p:spPr/>
+        <p:txBody>
+          <a:bodyPr/>
+          <a:lstStyle/>
+          <a:p>
+            <a:r>
+              <a:rPr lang="en-US" dirty="0"/>
+              <a:t>[Interaction 2 — ils votent à main levée. Rappel de la leçon + le point T-zone.]
+« Pour expandre ce palais à 12 ans, l'ancrage bicortical est-il indispensable ? » [vote]
+RÉVÉLATION : « Non. La résistance est quasi nulle — la vis ancre, elle ne force pas. Et il y a mieux : à cet âge, si on est dans la T-zone, on n'a même pas besoin de guide ni d'ancrage bicortical. 7 mm suffisent. À 16 ans, là, on ira volontiers chercher le bicortical — mais ça, c'est le cas suivant… » [pont vers Antoine]</a:t>
+            </a:r>
+            <a:endParaRPr lang="en-US" dirty="0"/>
+          </a:p>
+        </p:txBody>
+      </p:sp>
+      <p:sp>
+        <p:nvSpPr>
+          <p:cNvPr id="4" name="Slide Number Placeholder 3"/>
+          <p:cNvSpPr>
+            <a:spLocks noGrp="1"/>
+          </p:cNvSpPr>
+          <p:nvPr>
+            <p:ph type="sldNum" sz="quarter" idx="10"/>
+          </p:nvPr>
+        </p:nvSpPr>
+        <p:spPr/>
+        <p:txBody>
+          <a:bodyPr/>
+          <a:lstStyle/>
+          <a:p>
+            <a:fld id="{F7021451-1387-4CA6-816F-3879F97B5CBC}" type="slidenum">
+              <a:rPr lang="en-US"/>
+              <a:t>12</a:t>
+            </a:fld>
+            <a:endParaRPr lang="en-US"/>
+          </a:p>
+        </p:txBody>
+      </p:sp>
+    </p:spTree>
+    <p:extLst>
+      <p:ext uri="{BB962C8B-B14F-4D97-AF65-F5344CB8AC3E}">
+        <p14:creationId xmlns:p14="http://schemas.microsoft.com/office/powerpoint/2010/main" val="1024086991"/>
+      </p:ext>
+    </p:extLst>
+  </p:cSld>
+  <p:clrMapOvr>
+    <a:masterClrMapping/>
+  </p:clrMapOvr>
+</p:notes>
+</file>
+
+<file path=ppt/notesSlides/notesSlide13.xml><?xml version="1.0" encoding="utf-8"?>
+<p:notes xmlns:a="http://schemas.openxmlformats.org/drawingml/2006/main" xmlns:r="http://schemas.openxmlformats.org/officeDocument/2006/relationships" xmlns:p="http://schemas.openxmlformats.org/presentationml/2006/main">
+  <p:cSld>
+    <p:spTree>
+      <p:nvGrpSpPr>
+        <p:cNvPr id="1" name=""/>
+        <p:cNvGrpSpPr/>
+        <p:nvPr/>
+      </p:nvGrpSpPr>
+      <p:grpSpPr>
+        <a:xfrm>
+          <a:off x="0" y="0"/>
+          <a:ext cx="0" cy="0"/>
+          <a:chOff x="0" y="0"/>
+          <a:chExt cx="0" cy="0"/>
+        </a:xfrm>
+      </p:grpSpPr>
+      <p:sp>
+        <p:nvSpPr>
+          <p:cNvPr id="2" name="Slide Image Placeholder 1"/>
+          <p:cNvSpPr>
+            <a:spLocks noGrp="1" noRot="1" noChangeAspect="1"/>
+          </p:cNvSpPr>
+          <p:nvPr>
+            <p:ph type="sldImg"/>
+          </p:nvPr>
+        </p:nvSpPr>
+        <p:spPr/>
+      </p:sp>
+      <p:sp>
+        <p:nvSpPr>
+          <p:cNvPr id="3" name="Notes Placeholder 2"/>
+          <p:cNvSpPr>
+            <a:spLocks noGrp="1"/>
+          </p:cNvSpPr>
+          <p:nvPr>
+            <p:ph type="body" idx="1"/>
+          </p:nvPr>
+        </p:nvSpPr>
+        <p:spPr/>
+        <p:txBody>
+          <a:bodyPr/>
+          <a:lstStyle/>
+          <a:p>
+            <a:r>
+              <a:rPr lang="en-US" dirty="0"/>
+              <a:t>[Point 7 — tips. ÉNERGIE : creux technique, calme et précis.]
+T-zone : à cet âge, ni guide ni bicortical nécessaires. 7 mm d'ancrage suffisent (à présenter comme MA pratique, pas comme un seuil sourcé). Double charge (expansion + distalisation) → stabilité primaire bicorticale critique malgré tout. Séquence : [expand puis distalise / simultané]. Vigilance : bascule distale, rotation disto-palatine, dimension verticale. Mot sur le Micro II si pertinent.</a:t>
+            </a:r>
+            <a:endParaRPr lang="en-US" dirty="0"/>
+          </a:p>
+        </p:txBody>
+      </p:sp>
+      <p:sp>
+        <p:nvSpPr>
+          <p:cNvPr id="4" name="Slide Number Placeholder 3"/>
+          <p:cNvSpPr>
+            <a:spLocks noGrp="1"/>
+          </p:cNvSpPr>
+          <p:nvPr>
+            <p:ph type="sldNum" sz="quarter" idx="10"/>
+          </p:nvPr>
+        </p:nvSpPr>
+        <p:spPr/>
+        <p:txBody>
+          <a:bodyPr/>
+          <a:lstStyle/>
+          <a:p>
+            <a:fld id="{F7021451-1387-4CA6-816F-3879F97B5CBC}" type="slidenum">
+              <a:rPr lang="en-US"/>
+              <a:t>13</a:t>
+            </a:fld>
+            <a:endParaRPr lang="en-US"/>
+          </a:p>
+        </p:txBody>
+      </p:sp>
+    </p:spTree>
+    <p:extLst>
+      <p:ext uri="{BB962C8B-B14F-4D97-AF65-F5344CB8AC3E}">
+        <p14:creationId xmlns:p14="http://schemas.microsoft.com/office/powerpoint/2010/main" val="1024086991"/>
+      </p:ext>
+    </p:extLst>
+  </p:cSld>
+  <p:clrMapOvr>
+    <a:masterClrMapping/>
+  </p:clrMapOvr>
+</p:notes>
+</file>
+
+<file path=ppt/notesSlides/notesSlide14.xml><?xml version="1.0" encoding="utf-8"?>
+<p:notes xmlns:a="http://schemas.openxmlformats.org/drawingml/2006/main" xmlns:r="http://schemas.openxmlformats.org/officeDocument/2006/relationships" xmlns:p="http://schemas.openxmlformats.org/presentationml/2006/main">
+  <p:cSld>
+    <p:spTree>
+      <p:nvGrpSpPr>
+        <p:cNvPr id="1" name=""/>
+        <p:cNvGrpSpPr/>
+        <p:nvPr/>
+      </p:nvGrpSpPr>
+      <p:grpSpPr>
+        <a:xfrm>
+          <a:off x="0" y="0"/>
+          <a:ext cx="0" cy="0"/>
+          <a:chOff x="0" y="0"/>
+          <a:chExt cx="0" cy="0"/>
+        </a:xfrm>
+      </p:grpSpPr>
+      <p:sp>
+        <p:nvSpPr>
+          <p:cNvPr id="2" name="Slide Image Placeholder 1"/>
+          <p:cNvSpPr>
+            <a:spLocks noGrp="1" noRot="1" noChangeAspect="1"/>
+          </p:cNvSpPr>
+          <p:nvPr>
+            <p:ph type="sldImg"/>
+          </p:nvPr>
+        </p:nvSpPr>
+        <p:spPr/>
+      </p:sp>
+      <p:sp>
+        <p:nvSpPr>
+          <p:cNvPr id="3" name="Notes Placeholder 2"/>
+          <p:cNvSpPr>
+            <a:spLocks noGrp="1"/>
+          </p:cNvSpPr>
+          <p:nvPr>
+            <p:ph type="body" idx="1"/>
+          </p:nvPr>
+        </p:nvSpPr>
+        <p:spPr/>
+        <p:txBody>
+          <a:bodyPr/>
+          <a:lstStyle/>
+          <a:p>
+            <a:r>
+              <a:rPr lang="en-US" dirty="0"/>
+              <a:t>[Point 8 — LA distinction qu'Hermann trouvait floue. La marquer nettement, lentement, avec une pause entre les deux colonnes. Côté patient = émotion (sa vie) ; côté ortho = clinique (ta pratique).]
+« Pour lui, dans sa vie : traité au bon moment, une phase en moins, il aborde son adolescence avec une bouche fonctionnelle, il respire et dort mieux. [temps] Pour nous : un ancrage fiable même quand la denture ne suit pas, un geste simple, reproductible — et on repense la fenêtre d'intervention de toute une génération. »</a:t>
+            </a:r>
+            <a:endParaRPr lang="en-US" dirty="0"/>
+          </a:p>
+        </p:txBody>
+      </p:sp>
+      <p:sp>
+        <p:nvSpPr>
+          <p:cNvPr id="4" name="Slide Number Placeholder 3"/>
+          <p:cNvSpPr>
+            <a:spLocks noGrp="1"/>
+          </p:cNvSpPr>
+          <p:nvPr>
+            <p:ph type="sldNum" sz="quarter" idx="10"/>
+          </p:nvPr>
+        </p:nvSpPr>
+        <p:spPr/>
+        <p:txBody>
+          <a:bodyPr/>
+          <a:lstStyle/>
+          <a:p>
+            <a:fld id="{F7021451-1387-4CA6-816F-3879F97B5CBC}" type="slidenum">
+              <a:rPr lang="en-US"/>
+              <a:t>14</a:t>
+            </a:fld>
+            <a:endParaRPr lang="en-US"/>
+          </a:p>
+        </p:txBody>
+      </p:sp>
+    </p:spTree>
+    <p:extLst>
+      <p:ext uri="{BB962C8B-B14F-4D97-AF65-F5344CB8AC3E}">
+        <p14:creationId xmlns:p14="http://schemas.microsoft.com/office/powerpoint/2010/main" val="1024086991"/>
+      </p:ext>
+    </p:extLst>
+  </p:cSld>
+  <p:clrMapOvr>
+    <a:masterClrMapping/>
+  </p:clrMapOvr>
+</p:notes>
+</file>
+
+<file path=ppt/notesSlides/notesSlide15.xml><?xml version="1.0" encoding="utf-8"?>
+<p:notes xmlns:a="http://schemas.openxmlformats.org/drawingml/2006/main" xmlns:r="http://schemas.openxmlformats.org/officeDocument/2006/relationships" xmlns:p="http://schemas.openxmlformats.org/presentationml/2006/main">
+  <p:cSld>
+    <p:spTree>
+      <p:nvGrpSpPr>
+        <p:cNvPr id="1" name=""/>
+        <p:cNvGrpSpPr/>
+        <p:nvPr/>
+      </p:nvGrpSpPr>
+      <p:grpSpPr>
+        <a:xfrm>
+          <a:off x="0" y="0"/>
+          <a:ext cx="0" cy="0"/>
+          <a:chOff x="0" y="0"/>
+          <a:chExt cx="0" cy="0"/>
+        </a:xfrm>
+      </p:grpSpPr>
+      <p:sp>
+        <p:nvSpPr>
+          <p:cNvPr id="2" name="Slide Image Placeholder 1"/>
+          <p:cNvSpPr>
+            <a:spLocks noGrp="1" noRot="1" noChangeAspect="1"/>
+          </p:cNvSpPr>
+          <p:nvPr>
+            <p:ph type="sldImg"/>
+          </p:nvPr>
+        </p:nvSpPr>
+        <p:spPr/>
+      </p:sp>
+      <p:sp>
+        <p:nvSpPr>
+          <p:cNvPr id="3" name="Notes Placeholder 2"/>
+          <p:cNvSpPr>
+            <a:spLocks noGrp="1"/>
+          </p:cNvSpPr>
+          <p:nvPr>
+            <p:ph type="body" idx="1"/>
+          </p:nvPr>
+        </p:nvSpPr>
+        <p:spPr/>
+        <p:txBody>
+          <a:bodyPr/>
+          <a:lstStyle/>
+          <a:p>
+            <a:r>
+              <a:rPr lang="en-US" dirty="0"/>
+              <a:t>[LA CHUTE — marquer une coupure de voix avant (« Et si je devais résumer tout ça en une phrase… »), plus posée, plus large. Lance le cas suivant.]
+« Chez l'adulte, la vis vainc l'os. Chez l'enfant, elle ne vainc rien : elle ANCRE. Même outil, deux missions. Et c'est toute l'histoire des quatre-vingt-dix minutes qui viennent. »</a:t>
+            </a:r>
+            <a:endParaRPr lang="en-US" dirty="0"/>
+          </a:p>
+        </p:txBody>
+      </p:sp>
+      <p:sp>
+        <p:nvSpPr>
+          <p:cNvPr id="4" name="Slide Number Placeholder 3"/>
+          <p:cNvSpPr>
+            <a:spLocks noGrp="1"/>
+          </p:cNvSpPr>
+          <p:nvPr>
+            <p:ph type="sldNum" sz="quarter" idx="10"/>
+          </p:nvPr>
+        </p:nvSpPr>
+        <p:spPr/>
+        <p:txBody>
+          <a:bodyPr/>
+          <a:lstStyle/>
+          <a:p>
+            <a:fld id="{F7021451-1387-4CA6-816F-3879F97B5CBC}" type="slidenum">
+              <a:rPr lang="en-US"/>
+              <a:t>15</a:t>
             </a:fld>
             <a:endParaRPr lang="en-US"/>
           </a:p>
@@ -781,7 +1144,7 @@
               <a:rPr lang="en-US" dirty="0"/>
               <a:t>[Point 1 — Patient. Laisser parler les images, ne pas réciter la fiche. Poser une note humaine : c'est un enfant, on agit tôt, au bon moment.]
 Mathys, denture mixte, stade A-B d'Angelieri. Motif : [le sien]. Clinique : déficit transverse, encombrement, [Classe/fonction]. Radios : pano (germes), téléradio + mesures, occlusales, CBCT.
-[Émotion : ne pas dérouler une fiche — raconter un enfant, à l'âge où tout se joue.] 2</a:t>
+[Émotion : ne pas dérouler une fiche — raconter un enfant, à l'âge où tout se joue.]</a:t>
             </a:r>
             <a:endParaRPr lang="en-US" dirty="0"/>
           </a:p>
@@ -869,10 +1232,7 @@
           <a:p>
             <a:r>
               <a:rPr lang="en-US" dirty="0"/>
-              <a:t>[Points 2+3 — le plan (1er point) puis LA QUESTION. Ils réfléchissent. Formulation inclusive (Hermann : ne pas paraître moralisateur).]
-D'abord le plan, un seul point : MARPE + 2 vis de distalisation. On garde le pourquoi.
-« Comme Arnel vient de nous le montrer, l'enjeu des vis, c'est de vaincre la résistance du maxillaire. Alors la première idée à laquelle on pourrait TOUS penser, c'est : suture ouverte, stade A-B, aucune résistance… donc pas besoin de vis. [pause] Et pourtant, on en a mis. Si on regarde de plus près… pourquoi, à votre avis ? »
-[Repli sans Arnel : « On sait tous que l'intérêt premier des vis, c'est de vaincre la résistance… » — Se caler avec Arnel : sujet + ordre.] 3</a:t>
+              <a:t>[Documentation intra-orale — vues latérales et frontale.] Occlusion en intercuspidie : rapports transverses et sagittaux, encombrement.</a:t>
             </a:r>
             <a:endParaRPr lang="en-US" dirty="0"/>
           </a:p>
@@ -960,10 +1320,7 @@
           <a:p>
             <a:r>
               <a:rPr lang="en-US" dirty="0"/>
-              <a:t>[Point 4+5 — la science + les avantages. Cœur pédagogique, prendre le temps.]
-Chez le jeune, la suture cède ; le problème c'est l'ANCRAGE — les dents de lait ne tiennent pas. La vis remplace un ancrage défaillant.
-Appuis : Wilmes (dispositif pour ancrage dentaire réduit, âge moyen 11,2 ans, PMID 21490997) ; moins de bascule chez le patient en croissance (méta ≤16 ans, 10.3390/app15158326) ; protection de l'os alvéolaire (Copello, 10.1111/ocr.12374) ; distalisation sur ancrage palatin (Mohamed, 10.2319/091717-624.1).
-Avantages : expansion squelettique + recul Q1/Q2 sans compensation, avant éruption des 2es molaires. 4</a:t>
+              <a:t>[Vues occlusales — arcades maxillaire et mandibulaire.] Forme d'arcade, déficit transverse, encombrement.</a:t>
             </a:r>
             <a:endParaRPr lang="en-US" dirty="0"/>
           </a:p>
@@ -1051,8 +1408,7 @@
           <a:p>
             <a:r>
               <a:rPr lang="en-US" dirty="0"/>
-              <a:t>[Le dispositif — montrer, expliquer brièvement. La quincaillerie (marque, moteur) va dans le remis / QR, pas ici.]
-Vérin central d'expansion, deux vis de distalisation pour reculer les quadrants I et II, ancrage osseux paramédian. À cet âge, 7 mm suffisent. 5</a:t>
+              <a:t>[CBCT — suture médio-palatine ouverte, stade A-B d'Angelieri.] Support de la décision d'expansion et de l'ancrage osseux.</a:t>
             </a:r>
             <a:endParaRPr lang="en-US" dirty="0"/>
           </a:p>
@@ -1140,8 +1496,7 @@
           <a:p>
             <a:r>
               <a:rPr lang="en-US" dirty="0"/>
-              <a:t>[Point 6 — résultats. Laisser les images prouver, parler peu.]
-Avant/après : occlusales (gain transverse + recul des quadrants), profil, sourire. Évolution dans le temps. 6</a:t>
+              <a:t>[Téléradiographie de profil + analyse céphalométrique.] Rapports squelettiques et dentaires ; base des mesures.</a:t>
             </a:r>
             <a:endParaRPr lang="en-US" dirty="0"/>
           </a:p>
@@ -1229,10 +1584,10 @@
           <a:p>
             <a:r>
               <a:rPr lang="en-US" dirty="0"/>
-              <a:t>[La vidéo de pose — codes du démonstrateur (le vendeur de presse-jus) : TEMPO du geste, dédramatiser, PAS de vente. Muette, je commente en direct. Clip propre, court.]
-NARRATION (par-dessus la vidéo) :
-« On commence par endormir la surface. Puis quelques gouttes sur chaque site — quelques gouttes suffisent, on endort le périoste, pas l'os. On pose la vis. Le seul piège : on n'oriente pas perpendiculairement au plan sagittal — mais perpendiculairement à l'os qu'on aborde. La vis sur le tournevis, torque sur 35. Et là… pas de forcing — on ne pousse pas comme un malade, on visse. On avance… et on s'arrête net quand la tête touche la gencive. Un scan, têtes de vis nues, direction le labo. »
-[Puis, si dispo : témoignage patient « je n'ai rien senti ».] 7</a:t>
+              <a:t>[Points 2+3 — le plan (1er point) puis LA QUESTION. Ils réfléchissent. Formulation inclusive (Hermann : ne pas paraître moralisateur).]
+D'abord le plan, un seul point : MARPE + 2 vis de distalisation. On garde le pourquoi.
+« Comme Arnel vient de nous le montrer, l'enjeu des vis, c'est de vaincre la résistance du maxillaire. Alors la première idée à laquelle on pourrait TOUS penser, c'est : suture ouverte, stade A-B, aucune résistance… donc pas besoin de vis. [pause] Et pourtant, on en a mis. Si on regarde de plus près… pourquoi, à votre avis ? »
+[Repli sans Arnel : « On sait tous que l'intérêt premier des vis, c'est de vaincre la résistance… » — Se caler avec Arnel : sujet + ordre.]</a:t>
             </a:r>
             <a:endParaRPr lang="en-US" dirty="0"/>
           </a:p>
@@ -1320,9 +1675,10 @@
           <a:p>
             <a:r>
               <a:rPr lang="en-US" dirty="0"/>
-              <a:t>[Interaction 2 — ils votent à main levée. Rappel de la leçon + le point T-zone.]
-« Pour expandre ce palais à 12 ans, l'ancrage bicortical est-il indispensable ? » [vote]
-RÉVÉLATION : « Non. La résistance est quasi nulle — la vis ancre, elle ne force pas. Et il y a mieux : à cet âge, si on est dans la T-zone, on n'a même pas besoin de guide ni d'ancrage bicortical. 7 mm suffisent. À 16 ans, là, on ira volontiers chercher le bicortical — mais ça, c'est le cas suivant… » [pont vers Antoine] 8</a:t>
+              <a:t>[Point 4+5 — la science + les avantages. Cœur pédagogique, prendre le temps.]
+Chez le jeune, la suture cède ; le problème c'est l'ANCRAGE — les dents de lait ne tiennent pas. La vis remplace un ancrage défaillant.
+Appuis : Wilmes (dispositif pour ancrage dentaire réduit, âge moyen 11,2 ans, PMID 21490997) ; moins de bascule chez le patient en croissance (méta ≤16 ans, 10.3390/app15158326) ; protection de l'os alvéolaire (Copello, 10.1111/ocr.12374) ; distalisation sur ancrage palatin (Mohamed, 10.2319/091717-624.1).
+Avantages : expansion squelettique + recul Q1/Q2 sans compensation, avant éruption des 2es molaires.</a:t>
             </a:r>
             <a:endParaRPr lang="en-US" dirty="0"/>
           </a:p>
@@ -1410,8 +1766,8 @@
           <a:p>
             <a:r>
               <a:rPr lang="en-US" dirty="0"/>
-              <a:t>[Point 7 — tips. ÉNERGIE : creux technique, calme et précis.]
-T-zone : à cet âge, ni guide ni bicortical nécessaires. 7 mm d'ancrage suffisent (à présenter comme MA pratique, pas comme un seuil sourcé). Double charge (expansion + distalisation) → stabilité primaire bicorticale critique malgré tout. Séquence : [expand puis distalise / simultané]. Vigilance : bascule distale, rotation disto-palatine, dimension verticale. Mot sur le Micro II si pertinent. 9</a:t>
+              <a:t>[Le dispositif — montrer, expliquer brièvement. La quincaillerie (marque, moteur) va dans le remis / QR, pas ici.]
+Vérin central d'expansion, deux vis de distalisation pour reculer les quadrants I et II, ancrage osseux paramédian. À cet âge, 7 mm suffisent.</a:t>
             </a:r>
             <a:endParaRPr lang="en-US" dirty="0"/>
           </a:p>
@@ -1928,6 +2284,230 @@
 </p:sld>
 </file>
 
+<file path=ppt/slides/slide12.xml><?xml version="1.0" encoding="utf-8"?>
+<p:sld xmlns:a="http://schemas.openxmlformats.org/drawingml/2006/main" xmlns:r="http://schemas.openxmlformats.org/officeDocument/2006/relationships" xmlns:p="http://schemas.openxmlformats.org/presentationml/2006/main">
+  <p:cSld name="Slide 12">
+    <p:bg>
+      <p:bgPr>
+        <a:solidFill>
+          <a:srgbClr val="FAF7F1"/>
+        </a:solidFill>
+      </p:bgPr>
+    </p:bg>
+    <p:spTree>
+      <p:nvGrpSpPr>
+        <p:cNvPr id="1" name=""/>
+        <p:cNvGrpSpPr/>
+        <p:nvPr/>
+      </p:nvGrpSpPr>
+      <p:grpSpPr>
+        <a:xfrm>
+          <a:off x="0" y="0"/>
+          <a:ext cx="0" cy="0"/>
+          <a:chOff x="0" y="0"/>
+          <a:chExt cx="0" cy="0"/>
+        </a:xfrm>
+      </p:grpSpPr>
+      <p:pic>
+        <p:nvPicPr>
+          <p:cNvPr id="2" name="Image 0" descr="/home/user/Carrousel-TSS/deck/out/12.png">    </p:cNvPr>
+          <p:cNvPicPr>
+            <a:picLocks noChangeAspect="1"/>
+          </p:cNvPicPr>
+          <p:nvPr/>
+        </p:nvPicPr>
+        <p:blipFill>
+          <a:blip r:embed="rId1"/>
+          <a:stretch>
+            <a:fillRect/>
+          </a:stretch>
+        </p:blipFill>
+        <p:spPr>
+          <a:xfrm>
+            <a:off x="0" y="0"/>
+            <a:ext cx="12191695" cy="6858000"/>
+          </a:xfrm>
+          <a:prstGeom prst="rect">
+            <a:avLst/>
+          </a:prstGeom>
+        </p:spPr>
+      </p:pic>
+    </p:spTree>
+  </p:cSld>
+  <p:clrMapOvr>
+    <a:masterClrMapping/>
+  </p:clrMapOvr>
+</p:sld>
+</file>
+
+<file path=ppt/slides/slide13.xml><?xml version="1.0" encoding="utf-8"?>
+<p:sld xmlns:a="http://schemas.openxmlformats.org/drawingml/2006/main" xmlns:r="http://schemas.openxmlformats.org/officeDocument/2006/relationships" xmlns:p="http://schemas.openxmlformats.org/presentationml/2006/main">
+  <p:cSld name="Slide 13">
+    <p:bg>
+      <p:bgPr>
+        <a:solidFill>
+          <a:srgbClr val="FAF7F1"/>
+        </a:solidFill>
+      </p:bgPr>
+    </p:bg>
+    <p:spTree>
+      <p:nvGrpSpPr>
+        <p:cNvPr id="1" name=""/>
+        <p:cNvGrpSpPr/>
+        <p:nvPr/>
+      </p:nvGrpSpPr>
+      <p:grpSpPr>
+        <a:xfrm>
+          <a:off x="0" y="0"/>
+          <a:ext cx="0" cy="0"/>
+          <a:chOff x="0" y="0"/>
+          <a:chExt cx="0" cy="0"/>
+        </a:xfrm>
+      </p:grpSpPr>
+      <p:pic>
+        <p:nvPicPr>
+          <p:cNvPr id="2" name="Image 0" descr="/home/user/Carrousel-TSS/deck/out/13.png">    </p:cNvPr>
+          <p:cNvPicPr>
+            <a:picLocks noChangeAspect="1"/>
+          </p:cNvPicPr>
+          <p:nvPr/>
+        </p:nvPicPr>
+        <p:blipFill>
+          <a:blip r:embed="rId1"/>
+          <a:stretch>
+            <a:fillRect/>
+          </a:stretch>
+        </p:blipFill>
+        <p:spPr>
+          <a:xfrm>
+            <a:off x="0" y="0"/>
+            <a:ext cx="12191695" cy="6858000"/>
+          </a:xfrm>
+          <a:prstGeom prst="rect">
+            <a:avLst/>
+          </a:prstGeom>
+        </p:spPr>
+      </p:pic>
+    </p:spTree>
+  </p:cSld>
+  <p:clrMapOvr>
+    <a:masterClrMapping/>
+  </p:clrMapOvr>
+</p:sld>
+</file>
+
+<file path=ppt/slides/slide14.xml><?xml version="1.0" encoding="utf-8"?>
+<p:sld xmlns:a="http://schemas.openxmlformats.org/drawingml/2006/main" xmlns:r="http://schemas.openxmlformats.org/officeDocument/2006/relationships" xmlns:p="http://schemas.openxmlformats.org/presentationml/2006/main">
+  <p:cSld name="Slide 14">
+    <p:bg>
+      <p:bgPr>
+        <a:solidFill>
+          <a:srgbClr val="FAF7F1"/>
+        </a:solidFill>
+      </p:bgPr>
+    </p:bg>
+    <p:spTree>
+      <p:nvGrpSpPr>
+        <p:cNvPr id="1" name=""/>
+        <p:cNvGrpSpPr/>
+        <p:nvPr/>
+      </p:nvGrpSpPr>
+      <p:grpSpPr>
+        <a:xfrm>
+          <a:off x="0" y="0"/>
+          <a:ext cx="0" cy="0"/>
+          <a:chOff x="0" y="0"/>
+          <a:chExt cx="0" cy="0"/>
+        </a:xfrm>
+      </p:grpSpPr>
+      <p:pic>
+        <p:nvPicPr>
+          <p:cNvPr id="2" name="Image 0" descr="/home/user/Carrousel-TSS/deck/out/14.png">    </p:cNvPr>
+          <p:cNvPicPr>
+            <a:picLocks noChangeAspect="1"/>
+          </p:cNvPicPr>
+          <p:nvPr/>
+        </p:nvPicPr>
+        <p:blipFill>
+          <a:blip r:embed="rId1"/>
+          <a:stretch>
+            <a:fillRect/>
+          </a:stretch>
+        </p:blipFill>
+        <p:spPr>
+          <a:xfrm>
+            <a:off x="0" y="0"/>
+            <a:ext cx="12191695" cy="6858000"/>
+          </a:xfrm>
+          <a:prstGeom prst="rect">
+            <a:avLst/>
+          </a:prstGeom>
+        </p:spPr>
+      </p:pic>
+    </p:spTree>
+  </p:cSld>
+  <p:clrMapOvr>
+    <a:masterClrMapping/>
+  </p:clrMapOvr>
+</p:sld>
+</file>
+
+<file path=ppt/slides/slide15.xml><?xml version="1.0" encoding="utf-8"?>
+<p:sld xmlns:a="http://schemas.openxmlformats.org/drawingml/2006/main" xmlns:r="http://schemas.openxmlformats.org/officeDocument/2006/relationships" xmlns:p="http://schemas.openxmlformats.org/presentationml/2006/main">
+  <p:cSld name="Slide 15">
+    <p:bg>
+      <p:bgPr>
+        <a:solidFill>
+          <a:srgbClr val="FAF7F1"/>
+        </a:solidFill>
+      </p:bgPr>
+    </p:bg>
+    <p:spTree>
+      <p:nvGrpSpPr>
+        <p:cNvPr id="1" name=""/>
+        <p:cNvGrpSpPr/>
+        <p:nvPr/>
+      </p:nvGrpSpPr>
+      <p:grpSpPr>
+        <a:xfrm>
+          <a:off x="0" y="0"/>
+          <a:ext cx="0" cy="0"/>
+          <a:chOff x="0" y="0"/>
+          <a:chExt cx="0" cy="0"/>
+        </a:xfrm>
+      </p:grpSpPr>
+      <p:pic>
+        <p:nvPicPr>
+          <p:cNvPr id="2" name="Image 0" descr="/home/user/Carrousel-TSS/deck/out/15.png">    </p:cNvPr>
+          <p:cNvPicPr>
+            <a:picLocks noChangeAspect="1"/>
+          </p:cNvPicPr>
+          <p:nvPr/>
+        </p:nvPicPr>
+        <p:blipFill>
+          <a:blip r:embed="rId1"/>
+          <a:stretch>
+            <a:fillRect/>
+          </a:stretch>
+        </p:blipFill>
+        <p:spPr>
+          <a:xfrm>
+            <a:off x="0" y="0"/>
+            <a:ext cx="12191695" cy="6858000"/>
+          </a:xfrm>
+          <a:prstGeom prst="rect">
+            <a:avLst/>
+          </a:prstGeom>
+        </p:spPr>
+      </p:pic>
+    </p:spTree>
+  </p:cSld>
+  <p:clrMapOvr>
+    <a:masterClrMapping/>
+  </p:clrMapOvr>
+</p:sld>
+</file>
+
 <file path=ppt/slides/slide2.xml><?xml version="1.0" encoding="utf-8"?>
 <p:sld xmlns:a="http://schemas.openxmlformats.org/drawingml/2006/main" xmlns:r="http://schemas.openxmlformats.org/officeDocument/2006/relationships" xmlns:p="http://schemas.openxmlformats.org/presentationml/2006/main">
   <p:cSld name="Slide 2">

</xml_diff>